<commit_message>
Add Review 1 PPT with Abstract, Problem Statement, Objectives, Literature Review, Architecture, and Team Members
</commit_message>
<xml_diff>
--- a/Telemetry_Aware_Resilient_NIDPS_Comprehensive.pptx
+++ b/Telemetry_Aware_Resilient_NIDPS_Comprehensive.pptx
@@ -3222,8 +3222,8 @@
         </p:nvSpPr>
         <p:spPr>
           <a:xfrm>
-            <a:off x="914400" y="5120640"/>
-            <a:ext cx="10362895" cy="914400"/>
+            <a:off x="914400" y="4937760"/>
+            <a:ext cx="10362895" cy="1371600"/>
           </a:xfrm>
           <a:prstGeom prst="roundRect">
             <a:avLst/>
@@ -3267,8 +3267,8 @@
         </p:nvSpPr>
         <p:spPr>
           <a:xfrm>
-            <a:off x="1097280" y="5257800"/>
-            <a:ext cx="9966960" cy="640080"/>
+            <a:off x="1097280" y="5029200"/>
+            <a:ext cx="9966960" cy="1188720"/>
           </a:xfrm>
           <a:prstGeom prst="rect">
             <a:avLst/>
@@ -3282,14 +3282,29 @@
           <a:lstStyle/>
           <a:p>
             <a:pPr>
+              <a:spcAft>
+                <a:spcPts val="400"/>
+              </a:spcAft>
+              <a:defRPr sz="1300" b="1">
+                <a:solidFill>
+                  <a:srgbClr val="0EA5E9"/>
+                </a:solidFill>
+              </a:defRPr>
+            </a:pPr>
+            <a:r>
+              <a:t>TEAM:  THARAKESHA.M (Reg. No: 24BCE2538)   &amp;   BHARAT (Reg. No: 24BCB0056)</a:t>
+            </a:r>
+          </a:p>
+          <a:p>
+            <a:pPr>
               <a:defRPr sz="1100" b="1">
                 <a:solidFill>
-                  <a:srgbClr val="E2E8F0"/>
-                </a:solidFill>
-              </a:defRPr>
-            </a:pPr>
-            <a:r>
-              <a:t>Academic Research &amp; Capstone Defense | Benchmark Target: CIC-IDS2017 Dataset</a:t>
+                  <a:srgbClr val="F1F5F9"/>
+                </a:solidFill>
+              </a:defRPr>
+            </a:pPr>
+            <a:r>
+              <a:t>School of Computer Science and Engineering (SCOPE) • Vellore Institute of Technology (VIT)</a:t>
             </a:r>
           </a:p>
           <a:p>
@@ -3301,7 +3316,7 @@
               </a:defRPr>
             </a:pPr>
             <a:r>
-              <a:t>Department of Computer Science and Engineering • Cyber Defense &amp; Resilient Machine Learning</a:t>
+              <a:t>Review 1 Defense • Target Benchmark: CIC-IDS2017 Dataset • Live Demo: https://resilient-nidps.streamlit.app</a:t>
             </a:r>
           </a:p>
         </p:txBody>

</xml_diff>